<commit_message>
update chair slides - document status
</commit_message>
<xml_diff>
--- a/ietf126-Vienna/slides/chair-slides-bmwg-ippm1.pptx
+++ b/ietf126-Vienna/slides/chair-slides-bmwg-ippm1.pptx
@@ -317,564 +317,29 @@
 </p:presentation>
 </file>
 
-<file path=ppt/revisionInfo.xml><?xml version="1.0" encoding="utf-8"?>
-<p1510:revInfo xmlns:a="http://schemas.openxmlformats.org/drawingml/2006/main" xmlns:r="http://schemas.openxmlformats.org/officeDocument/2006/relationships" xmlns:p1510="http://schemas.microsoft.com/office/powerpoint/2015/10/main">
-  <p1510:revLst>
-    <p1510:client id="{95030CFF-6EB8-4A6F-AC26-1A45B7C3A0D4}" v="61" dt="2026-07-16T10:09:19.602"/>
-  </p1510:revLst>
-</p1510:revInfo>
-</file>
-
 <file path=ppt/changesInfos/changesInfo1.xml><?xml version="1.0" encoding="utf-8"?>
 <pc:chgInfo xmlns:a="http://schemas.openxmlformats.org/drawingml/2006/main" xmlns:r="http://schemas.openxmlformats.org/officeDocument/2006/relationships" xmlns:ac="http://schemas.microsoft.com/office/drawing/2013/main/command" xmlns:pc="http://schemas.microsoft.com/office/powerpoint/2013/main/command">
   <pc:docChgLst>
-    <pc:chgData name="Graf Thomas, SCS-INI-NET-VNC-E2E" userId="487bc3e3-9ce7-4cdd-b7b4-8899ea88d289" providerId="ADAL" clId="{52F89B06-B397-4BA4-9DB6-8A81C30956C2}"/>
-    <pc:docChg chg="addSld delSld modSld">
-      <pc:chgData name="Graf Thomas, SCS-INI-NET-VNC-E2E" userId="487bc3e3-9ce7-4cdd-b7b4-8899ea88d289" providerId="ADAL" clId="{52F89B06-B397-4BA4-9DB6-8A81C30956C2}" dt="2025-11-04T14:39:54.897" v="2" actId="47"/>
-      <pc:docMkLst>
-        <pc:docMk/>
-      </pc:docMkLst>
-      <pc:sldChg chg="del">
-        <pc:chgData name="Graf Thomas, SCS-INI-NET-VNC-E2E" userId="487bc3e3-9ce7-4cdd-b7b4-8899ea88d289" providerId="ADAL" clId="{52F89B06-B397-4BA4-9DB6-8A81C30956C2}" dt="2025-11-04T14:39:54.897" v="2" actId="47"/>
-        <pc:sldMkLst>
-          <pc:docMk/>
-          <pc:sldMk cId="0" sldId="257"/>
-        </pc:sldMkLst>
-      </pc:sldChg>
-      <pc:sldChg chg="add del">
-        <pc:chgData name="Graf Thomas, SCS-INI-NET-VNC-E2E" userId="487bc3e3-9ce7-4cdd-b7b4-8899ea88d289" providerId="ADAL" clId="{52F89B06-B397-4BA4-9DB6-8A81C30956C2}" dt="2025-11-04T14:39:38.974" v="1"/>
-        <pc:sldMkLst>
-          <pc:docMk/>
-          <pc:sldMk cId="0" sldId="272"/>
-        </pc:sldMkLst>
-      </pc:sldChg>
-    </pc:docChg>
-  </pc:docChgLst>
-  <pc:docChgLst>
-    <pc:chgData name="Marcus Ihlar" userId="3466507a-8f95-47f2-ae1b-ce7d6ca611a4" providerId="ADAL" clId="{AED546ED-D998-4FD7-8756-673BE2DDCF49}"/>
-    <pc:docChg chg="modSld">
-      <pc:chgData name="Marcus Ihlar" userId="3466507a-8f95-47f2-ae1b-ce7d6ca611a4" providerId="ADAL" clId="{AED546ED-D998-4FD7-8756-673BE2DDCF49}" dt="2025-07-16T10:35:22.434" v="10" actId="20577"/>
+    <pc:chgData name="Marcus Ihlar" userId="3466507a-8f95-47f2-ae1b-ce7d6ca611a4" providerId="ADAL" clId="{3438F4FC-D214-4A35-B915-405844213C8B}"/>
+    <pc:docChg chg="undo custSel modSld">
+      <pc:chgData name="Marcus Ihlar" userId="3466507a-8f95-47f2-ae1b-ce7d6ca611a4" providerId="ADAL" clId="{3438F4FC-D214-4A35-B915-405844213C8B}" dt="2026-07-22T07:31:56.144" v="2" actId="20577"/>
       <pc:docMkLst>
         <pc:docMk/>
       </pc:docMkLst>
       <pc:sldChg chg="modSp mod">
-        <pc:chgData name="Marcus Ihlar" userId="3466507a-8f95-47f2-ae1b-ce7d6ca611a4" providerId="ADAL" clId="{AED546ED-D998-4FD7-8756-673BE2DDCF49}" dt="2025-07-16T10:35:22.434" v="10" actId="20577"/>
-        <pc:sldMkLst>
-          <pc:docMk/>
-          <pc:sldMk cId="0" sldId="256"/>
-        </pc:sldMkLst>
-      </pc:sldChg>
-      <pc:sldChg chg="modSp mod">
-        <pc:chgData name="Marcus Ihlar" userId="3466507a-8f95-47f2-ae1b-ce7d6ca611a4" providerId="ADAL" clId="{AED546ED-D998-4FD7-8756-673BE2DDCF49}" dt="2025-07-16T10:18:57.833" v="8" actId="20577"/>
-        <pc:sldMkLst>
-          <pc:docMk/>
-          <pc:sldMk cId="2128497270" sldId="269"/>
-        </pc:sldMkLst>
-      </pc:sldChg>
-    </pc:docChg>
-  </pc:docChgLst>
-  <pc:docChgLst>
-    <pc:chgData name="Graf Thomas, SCS-INI-NET-VNC-E2E" userId="487bc3e3-9ce7-4cdd-b7b4-8899ea88d289" providerId="ADAL" clId="{4403439A-50EC-49D8-B7F6-3D7264685FDE}"/>
-    <pc:docChg chg="undo custSel addSld modSld sldOrd">
-      <pc:chgData name="Graf Thomas, SCS-INI-NET-VNC-E2E" userId="487bc3e3-9ce7-4cdd-b7b4-8899ea88d289" providerId="ADAL" clId="{4403439A-50EC-49D8-B7F6-3D7264685FDE}" dt="2025-07-21T05:25:01.641" v="1423" actId="1076"/>
-      <pc:docMkLst>
-        <pc:docMk/>
-      </pc:docMkLst>
-      <pc:sldChg chg="modSp mod">
-        <pc:chgData name="Graf Thomas, SCS-INI-NET-VNC-E2E" userId="487bc3e3-9ce7-4cdd-b7b4-8899ea88d289" providerId="ADAL" clId="{4403439A-50EC-49D8-B7F6-3D7264685FDE}" dt="2025-07-10T05:43:59.555" v="6" actId="20577"/>
-        <pc:sldMkLst>
-          <pc:docMk/>
-          <pc:sldMk cId="0" sldId="256"/>
-        </pc:sldMkLst>
-      </pc:sldChg>
-      <pc:sldChg chg="ord">
-        <pc:chgData name="Graf Thomas, SCS-INI-NET-VNC-E2E" userId="487bc3e3-9ce7-4cdd-b7b4-8899ea88d289" providerId="ADAL" clId="{4403439A-50EC-49D8-B7F6-3D7264685FDE}" dt="2025-07-10T06:22:20.341" v="686"/>
-        <pc:sldMkLst>
-          <pc:docMk/>
-          <pc:sldMk cId="0" sldId="259"/>
-        </pc:sldMkLst>
-      </pc:sldChg>
-      <pc:sldChg chg="modSp mod">
-        <pc:chgData name="Graf Thomas, SCS-INI-NET-VNC-E2E" userId="487bc3e3-9ce7-4cdd-b7b4-8899ea88d289" providerId="ADAL" clId="{4403439A-50EC-49D8-B7F6-3D7264685FDE}" dt="2025-07-10T05:48:14.572" v="76" actId="20577"/>
-        <pc:sldMkLst>
-          <pc:docMk/>
-          <pc:sldMk cId="0" sldId="260"/>
-        </pc:sldMkLst>
-      </pc:sldChg>
-      <pc:sldChg chg="modSp mod">
-        <pc:chgData name="Graf Thomas, SCS-INI-NET-VNC-E2E" userId="487bc3e3-9ce7-4cdd-b7b4-8899ea88d289" providerId="ADAL" clId="{4403439A-50EC-49D8-B7F6-3D7264685FDE}" dt="2025-07-10T05:44:34.935" v="15" actId="20577"/>
-        <pc:sldMkLst>
-          <pc:docMk/>
-          <pc:sldMk cId="3471097262" sldId="261"/>
-        </pc:sldMkLst>
-      </pc:sldChg>
-      <pc:sldChg chg="addSp delSp modSp mod">
-        <pc:chgData name="Graf Thomas, SCS-INI-NET-VNC-E2E" userId="487bc3e3-9ce7-4cdd-b7b4-8899ea88d289" providerId="ADAL" clId="{4403439A-50EC-49D8-B7F6-3D7264685FDE}" dt="2025-07-21T05:25:01.641" v="1423" actId="1076"/>
-        <pc:sldMkLst>
-          <pc:docMk/>
-          <pc:sldMk cId="2332748115" sldId="263"/>
-        </pc:sldMkLst>
-      </pc:sldChg>
-      <pc:sldChg chg="addSp delSp modSp mod">
-        <pc:chgData name="Graf Thomas, SCS-INI-NET-VNC-E2E" userId="487bc3e3-9ce7-4cdd-b7b4-8899ea88d289" providerId="ADAL" clId="{4403439A-50EC-49D8-B7F6-3D7264685FDE}" dt="2025-07-14T15:38:27.636" v="757" actId="1076"/>
-        <pc:sldMkLst>
-          <pc:docMk/>
-          <pc:sldMk cId="703495152" sldId="264"/>
-        </pc:sldMkLst>
-      </pc:sldChg>
-      <pc:sldChg chg="modSp mod">
-        <pc:chgData name="Graf Thomas, SCS-INI-NET-VNC-E2E" userId="487bc3e3-9ce7-4cdd-b7b4-8899ea88d289" providerId="ADAL" clId="{4403439A-50EC-49D8-B7F6-3D7264685FDE}" dt="2025-07-10T06:06:38.835" v="223" actId="14100"/>
-        <pc:sldMkLst>
-          <pc:docMk/>
-          <pc:sldMk cId="1372742302" sldId="266"/>
-        </pc:sldMkLst>
-      </pc:sldChg>
-      <pc:sldChg chg="modSp add mod">
-        <pc:chgData name="Graf Thomas, SCS-INI-NET-VNC-E2E" userId="487bc3e3-9ce7-4cdd-b7b4-8899ea88d289" providerId="ADAL" clId="{4403439A-50EC-49D8-B7F6-3D7264685FDE}" dt="2025-07-10T06:00:40.529" v="209" actId="20577"/>
-        <pc:sldMkLst>
-          <pc:docMk/>
-          <pc:sldMk cId="1383312952" sldId="267"/>
-        </pc:sldMkLst>
-      </pc:sldChg>
-      <pc:sldChg chg="modSp add mod ord">
-        <pc:chgData name="Graf Thomas, SCS-INI-NET-VNC-E2E" userId="487bc3e3-9ce7-4cdd-b7b4-8899ea88d289" providerId="ADAL" clId="{4403439A-50EC-49D8-B7F6-3D7264685FDE}" dt="2025-07-10T06:00:34.413" v="207" actId="20577"/>
-        <pc:sldMkLst>
-          <pc:docMk/>
-          <pc:sldMk cId="1659843495" sldId="268"/>
-        </pc:sldMkLst>
-      </pc:sldChg>
-      <pc:sldChg chg="modSp add mod">
-        <pc:chgData name="Graf Thomas, SCS-INI-NET-VNC-E2E" userId="487bc3e3-9ce7-4cdd-b7b4-8899ea88d289" providerId="ADAL" clId="{4403439A-50EC-49D8-B7F6-3D7264685FDE}" dt="2025-07-10T06:19:40.757" v="684" actId="20577"/>
-        <pc:sldMkLst>
-          <pc:docMk/>
-          <pc:sldMk cId="2128497270" sldId="269"/>
-        </pc:sldMkLst>
-      </pc:sldChg>
-      <pc:sldChg chg="modSp add mod ord">
-        <pc:chgData name="Graf Thomas, SCS-INI-NET-VNC-E2E" userId="487bc3e3-9ce7-4cdd-b7b4-8899ea88d289" providerId="ADAL" clId="{4403439A-50EC-49D8-B7F6-3D7264685FDE}" dt="2025-07-15T09:01:50.650" v="1407" actId="20577"/>
-        <pc:sldMkLst>
-          <pc:docMk/>
-          <pc:sldMk cId="2434865477" sldId="270"/>
-        </pc:sldMkLst>
-      </pc:sldChg>
-      <pc:sldChg chg="addSp delSp modSp add mod">
-        <pc:chgData name="Graf Thomas, SCS-INI-NET-VNC-E2E" userId="487bc3e3-9ce7-4cdd-b7b4-8899ea88d289" providerId="ADAL" clId="{4403439A-50EC-49D8-B7F6-3D7264685FDE}" dt="2025-07-14T15:38:57.390" v="780" actId="1076"/>
-        <pc:sldMkLst>
-          <pc:docMk/>
-          <pc:sldMk cId="1859012803" sldId="271"/>
-        </pc:sldMkLst>
-      </pc:sldChg>
-    </pc:docChg>
-  </pc:docChgLst>
-  <pc:docChgLst>
-    <pc:chgData name="Graf Thomas, SCS-INI-NET-VNC-E2E" userId="487bc3e3-9ce7-4cdd-b7b4-8899ea88d289" providerId="ADAL" clId="{ADEEF08A-D719-4B50-A383-4105EDA2C206}"/>
-    <pc:docChg chg="undo custSel addSld delSld modSld sldOrd">
-      <pc:chgData name="Graf Thomas, SCS-INI-NET-VNC-E2E" userId="487bc3e3-9ce7-4cdd-b7b4-8899ea88d289" providerId="ADAL" clId="{ADEEF08A-D719-4B50-A383-4105EDA2C206}" dt="2026-07-22T04:50:58.353" v="2555" actId="1076"/>
-      <pc:docMkLst>
-        <pc:docMk/>
-      </pc:docMkLst>
-      <pc:sldChg chg="modSp mod">
-        <pc:chgData name="Graf Thomas, SCS-INI-NET-VNC-E2E" userId="487bc3e3-9ce7-4cdd-b7b4-8899ea88d289" providerId="ADAL" clId="{ADEEF08A-D719-4B50-A383-4105EDA2C206}" dt="2026-07-16T09:07:51.053" v="863" actId="20577"/>
-        <pc:sldMkLst>
-          <pc:docMk/>
-          <pc:sldMk cId="0" sldId="256"/>
-        </pc:sldMkLst>
-        <pc:spChg chg="mod">
-          <ac:chgData name="Graf Thomas, SCS-INI-NET-VNC-E2E" userId="487bc3e3-9ce7-4cdd-b7b4-8899ea88d289" providerId="ADAL" clId="{ADEEF08A-D719-4B50-A383-4105EDA2C206}" dt="2026-07-16T09:07:51.053" v="863" actId="20577"/>
-          <ac:spMkLst>
-            <pc:docMk/>
-            <pc:sldMk cId="0" sldId="256"/>
-            <ac:spMk id="99" creationId="{00000000-0000-0000-0000-000000000000}"/>
-          </ac:spMkLst>
-        </pc:spChg>
-        <pc:spChg chg="mod">
-          <ac:chgData name="Graf Thomas, SCS-INI-NET-VNC-E2E" userId="487bc3e3-9ce7-4cdd-b7b4-8899ea88d289" providerId="ADAL" clId="{ADEEF08A-D719-4B50-A383-4105EDA2C206}" dt="2026-07-16T09:07:46.035" v="858" actId="20577"/>
-          <ac:spMkLst>
-            <pc:docMk/>
-            <pc:sldMk cId="0" sldId="256"/>
-            <ac:spMk id="100" creationId="{00000000-0000-0000-0000-000000000000}"/>
-          </ac:spMkLst>
-        </pc:spChg>
-      </pc:sldChg>
-      <pc:sldChg chg="modSp mod">
-        <pc:chgData name="Graf Thomas, SCS-INI-NET-VNC-E2E" userId="487bc3e3-9ce7-4cdd-b7b4-8899ea88d289" providerId="ADAL" clId="{ADEEF08A-D719-4B50-A383-4105EDA2C206}" dt="2026-07-16T09:09:16.330" v="864" actId="20577"/>
-        <pc:sldMkLst>
-          <pc:docMk/>
-          <pc:sldMk cId="0" sldId="259"/>
-        </pc:sldMkLst>
-        <pc:spChg chg="mod">
-          <ac:chgData name="Graf Thomas, SCS-INI-NET-VNC-E2E" userId="487bc3e3-9ce7-4cdd-b7b4-8899ea88d289" providerId="ADAL" clId="{ADEEF08A-D719-4B50-A383-4105EDA2C206}" dt="2026-07-16T09:09:16.330" v="864" actId="20577"/>
-          <ac:spMkLst>
-            <pc:docMk/>
-            <pc:sldMk cId="0" sldId="259"/>
-            <ac:spMk id="119" creationId="{00000000-0000-0000-0000-000000000000}"/>
-          </ac:spMkLst>
-        </pc:spChg>
-      </pc:sldChg>
-      <pc:sldChg chg="modSp mod modShow">
-        <pc:chgData name="Graf Thomas, SCS-INI-NET-VNC-E2E" userId="487bc3e3-9ce7-4cdd-b7b4-8899ea88d289" providerId="ADAL" clId="{ADEEF08A-D719-4B50-A383-4105EDA2C206}" dt="2026-07-16T09:19:45.843" v="1133" actId="20577"/>
-        <pc:sldMkLst>
-          <pc:docMk/>
-          <pc:sldMk cId="0" sldId="260"/>
-        </pc:sldMkLst>
-        <pc:spChg chg="mod">
-          <ac:chgData name="Graf Thomas, SCS-INI-NET-VNC-E2E" userId="487bc3e3-9ce7-4cdd-b7b4-8899ea88d289" providerId="ADAL" clId="{ADEEF08A-D719-4B50-A383-4105EDA2C206}" dt="2026-07-16T09:19:45.843" v="1133" actId="20577"/>
-          <ac:spMkLst>
-            <pc:docMk/>
-            <pc:sldMk cId="0" sldId="260"/>
-            <ac:spMk id="128" creationId="{00000000-0000-0000-0000-000000000000}"/>
-          </ac:spMkLst>
-        </pc:spChg>
-      </pc:sldChg>
-      <pc:sldChg chg="modSp mod">
-        <pc:chgData name="Graf Thomas, SCS-INI-NET-VNC-E2E" userId="487bc3e3-9ce7-4cdd-b7b4-8899ea88d289" providerId="ADAL" clId="{ADEEF08A-D719-4B50-A383-4105EDA2C206}" dt="2026-07-16T09:14:13.187" v="1068" actId="20577"/>
-        <pc:sldMkLst>
-          <pc:docMk/>
-          <pc:sldMk cId="3471097262" sldId="261"/>
-        </pc:sldMkLst>
-        <pc:spChg chg="mod">
-          <ac:chgData name="Graf Thomas, SCS-INI-NET-VNC-E2E" userId="487bc3e3-9ce7-4cdd-b7b4-8899ea88d289" providerId="ADAL" clId="{ADEEF08A-D719-4B50-A383-4105EDA2C206}" dt="2026-07-16T09:14:13.187" v="1068" actId="20577"/>
-          <ac:spMkLst>
-            <pc:docMk/>
-            <pc:sldMk cId="3471097262" sldId="261"/>
-            <ac:spMk id="3" creationId="{DA4A6F5D-9442-B583-BAB9-5A102B90EC22}"/>
-          </ac:spMkLst>
-        </pc:spChg>
-      </pc:sldChg>
-      <pc:sldChg chg="addSp delSp modSp mod">
-        <pc:chgData name="Graf Thomas, SCS-INI-NET-VNC-E2E" userId="487bc3e3-9ce7-4cdd-b7b4-8899ea88d289" providerId="ADAL" clId="{ADEEF08A-D719-4B50-A383-4105EDA2C206}" dt="2026-07-22T04:50:22.519" v="2548" actId="1076"/>
-        <pc:sldMkLst>
-          <pc:docMk/>
-          <pc:sldMk cId="2332748115" sldId="263"/>
-        </pc:sldMkLst>
-        <pc:picChg chg="add mod">
-          <ac:chgData name="Graf Thomas, SCS-INI-NET-VNC-E2E" userId="487bc3e3-9ce7-4cdd-b7b4-8899ea88d289" providerId="ADAL" clId="{ADEEF08A-D719-4B50-A383-4105EDA2C206}" dt="2026-07-22T04:50:22.519" v="2548" actId="1076"/>
-          <ac:picMkLst>
-            <pc:docMk/>
-            <pc:sldMk cId="2332748115" sldId="263"/>
-            <ac:picMk id="5" creationId="{1651A5FE-BC22-A772-4A2B-C1C3EDC951C6}"/>
-          </ac:picMkLst>
-        </pc:picChg>
-        <pc:picChg chg="add del mod">
-          <ac:chgData name="Graf Thomas, SCS-INI-NET-VNC-E2E" userId="487bc3e3-9ce7-4cdd-b7b4-8899ea88d289" providerId="ADAL" clId="{ADEEF08A-D719-4B50-A383-4105EDA2C206}" dt="2026-07-22T04:50:18.837" v="2546" actId="478"/>
-          <ac:picMkLst>
-            <pc:docMk/>
-            <pc:sldMk cId="2332748115" sldId="263"/>
-            <ac:picMk id="6" creationId="{7B4B8BD9-E06D-0001-0C06-F7A8BE76638F}"/>
-          </ac:picMkLst>
-        </pc:picChg>
-      </pc:sldChg>
-      <pc:sldChg chg="addSp delSp modSp mod">
-        <pc:chgData name="Graf Thomas, SCS-INI-NET-VNC-E2E" userId="487bc3e3-9ce7-4cdd-b7b4-8899ea88d289" providerId="ADAL" clId="{ADEEF08A-D719-4B50-A383-4105EDA2C206}" dt="2026-07-22T04:50:39.782" v="2552" actId="1076"/>
-        <pc:sldMkLst>
-          <pc:docMk/>
-          <pc:sldMk cId="703495152" sldId="264"/>
-        </pc:sldMkLst>
-        <pc:picChg chg="add del mod">
-          <ac:chgData name="Graf Thomas, SCS-INI-NET-VNC-E2E" userId="487bc3e3-9ce7-4cdd-b7b4-8899ea88d289" providerId="ADAL" clId="{ADEEF08A-D719-4B50-A383-4105EDA2C206}" dt="2026-07-22T04:49:38.974" v="2542" actId="478"/>
-          <ac:picMkLst>
-            <pc:docMk/>
-            <pc:sldMk cId="703495152" sldId="264"/>
-            <ac:picMk id="5" creationId="{C8BC6838-A831-553D-9CC4-BCCCA60BD7FC}"/>
-          </ac:picMkLst>
-        </pc:picChg>
-        <pc:picChg chg="add del mod">
-          <ac:chgData name="Graf Thomas, SCS-INI-NET-VNC-E2E" userId="487bc3e3-9ce7-4cdd-b7b4-8899ea88d289" providerId="ADAL" clId="{ADEEF08A-D719-4B50-A383-4105EDA2C206}" dt="2026-07-22T04:49:49.775" v="2545" actId="478"/>
-          <ac:picMkLst>
-            <pc:docMk/>
-            <pc:sldMk cId="703495152" sldId="264"/>
-            <ac:picMk id="6" creationId="{827AD177-E2DC-8BB8-AEE6-5FEEDDA39E6A}"/>
-          </ac:picMkLst>
-        </pc:picChg>
-        <pc:picChg chg="add mod">
-          <ac:chgData name="Graf Thomas, SCS-INI-NET-VNC-E2E" userId="487bc3e3-9ce7-4cdd-b7b4-8899ea88d289" providerId="ADAL" clId="{ADEEF08A-D719-4B50-A383-4105EDA2C206}" dt="2026-07-22T04:50:39.782" v="2552" actId="1076"/>
-          <ac:picMkLst>
-            <pc:docMk/>
-            <pc:sldMk cId="703495152" sldId="264"/>
-            <ac:picMk id="8" creationId="{DDD54163-A364-7404-5FA2-B9996C09DC5C}"/>
-          </ac:picMkLst>
-        </pc:picChg>
-      </pc:sldChg>
-      <pc:sldChg chg="addSp delSp modSp mod">
-        <pc:chgData name="Graf Thomas, SCS-INI-NET-VNC-E2E" userId="487bc3e3-9ce7-4cdd-b7b4-8899ea88d289" providerId="ADAL" clId="{ADEEF08A-D719-4B50-A383-4105EDA2C206}" dt="2026-07-16T10:02:18.705" v="2325" actId="22"/>
-        <pc:sldMkLst>
-          <pc:docMk/>
-          <pc:sldMk cId="1372742302" sldId="266"/>
-        </pc:sldMkLst>
-        <pc:spChg chg="mod">
-          <ac:chgData name="Graf Thomas, SCS-INI-NET-VNC-E2E" userId="487bc3e3-9ce7-4cdd-b7b4-8899ea88d289" providerId="ADAL" clId="{ADEEF08A-D719-4B50-A383-4105EDA2C206}" dt="2026-07-16T09:18:48.162" v="1124" actId="20577"/>
-          <ac:spMkLst>
-            <pc:docMk/>
-            <pc:sldMk cId="1372742302" sldId="266"/>
-            <ac:spMk id="2" creationId="{0B9E15DC-F076-98D2-1BDF-BC01FEC9047B}"/>
-          </ac:spMkLst>
-        </pc:spChg>
-        <pc:spChg chg="mod">
-          <ac:chgData name="Graf Thomas, SCS-INI-NET-VNC-E2E" userId="487bc3e3-9ce7-4cdd-b7b4-8899ea88d289" providerId="ADAL" clId="{ADEEF08A-D719-4B50-A383-4105EDA2C206}" dt="2026-07-16T09:57:35.829" v="2212" actId="20577"/>
-          <ac:spMkLst>
-            <pc:docMk/>
-            <pc:sldMk cId="1372742302" sldId="266"/>
-            <ac:spMk id="3" creationId="{FED4E835-D652-159B-D0CD-7FC58A509645}"/>
-          </ac:spMkLst>
-        </pc:spChg>
-      </pc:sldChg>
-      <pc:sldChg chg="modSp mod">
-        <pc:chgData name="Graf Thomas, SCS-INI-NET-VNC-E2E" userId="487bc3e3-9ce7-4cdd-b7b4-8899ea88d289" providerId="ADAL" clId="{ADEEF08A-D719-4B50-A383-4105EDA2C206}" dt="2026-07-16T10:09:20.508" v="2524" actId="6549"/>
+        <pc:chgData name="Marcus Ihlar" userId="3466507a-8f95-47f2-ae1b-ce7d6ca611a4" providerId="ADAL" clId="{3438F4FC-D214-4A35-B915-405844213C8B}" dt="2026-07-22T07:31:56.144" v="2" actId="20577"/>
         <pc:sldMkLst>
           <pc:docMk/>
           <pc:sldMk cId="2128497270" sldId="269"/>
         </pc:sldMkLst>
         <pc:spChg chg="mod">
-          <ac:chgData name="Graf Thomas, SCS-INI-NET-VNC-E2E" userId="487bc3e3-9ce7-4cdd-b7b4-8899ea88d289" providerId="ADAL" clId="{ADEEF08A-D719-4B50-A383-4105EDA2C206}" dt="2026-07-16T10:06:13.713" v="2431" actId="790"/>
-          <ac:spMkLst>
-            <pc:docMk/>
-            <pc:sldMk cId="2128497270" sldId="269"/>
-            <ac:spMk id="2" creationId="{0B9E15DC-F076-98D2-1BDF-BC01FEC9047B}"/>
-          </ac:spMkLst>
-        </pc:spChg>
-        <pc:spChg chg="mod">
-          <ac:chgData name="Graf Thomas, SCS-INI-NET-VNC-E2E" userId="487bc3e3-9ce7-4cdd-b7b4-8899ea88d289" providerId="ADAL" clId="{ADEEF08A-D719-4B50-A383-4105EDA2C206}" dt="2026-07-16T10:09:20.508" v="2524" actId="6549"/>
+          <ac:chgData name="Marcus Ihlar" userId="3466507a-8f95-47f2-ae1b-ce7d6ca611a4" providerId="ADAL" clId="{3438F4FC-D214-4A35-B915-405844213C8B}" dt="2026-07-22T07:31:56.144" v="2" actId="20577"/>
           <ac:spMkLst>
             <pc:docMk/>
             <pc:sldMk cId="2128497270" sldId="269"/>
             <ac:spMk id="3" creationId="{FED4E835-D652-159B-D0CD-7FC58A509645}"/>
           </ac:spMkLst>
         </pc:spChg>
-        <pc:spChg chg="mod">
-          <ac:chgData name="Graf Thomas, SCS-INI-NET-VNC-E2E" userId="487bc3e3-9ce7-4cdd-b7b4-8899ea88d289" providerId="ADAL" clId="{ADEEF08A-D719-4B50-A383-4105EDA2C206}" dt="2026-07-16T10:06:13.713" v="2431" actId="790"/>
-          <ac:spMkLst>
-            <pc:docMk/>
-            <pc:sldMk cId="2128497270" sldId="269"/>
-            <ac:spMk id="4" creationId="{D216BDC7-4DE9-D9D5-0725-BBEF6CFE8DF1}"/>
-          </ac:spMkLst>
-        </pc:spChg>
-      </pc:sldChg>
-      <pc:sldChg chg="modSp del mod">
-        <pc:chgData name="Graf Thomas, SCS-INI-NET-VNC-E2E" userId="487bc3e3-9ce7-4cdd-b7b4-8899ea88d289" providerId="ADAL" clId="{ADEEF08A-D719-4B50-A383-4105EDA2C206}" dt="2026-07-16T09:17:11.420" v="1113" actId="2696"/>
-        <pc:sldMkLst>
-          <pc:docMk/>
-          <pc:sldMk cId="2434865477" sldId="270"/>
-        </pc:sldMkLst>
-      </pc:sldChg>
-      <pc:sldChg chg="addSp delSp modSp mod">
-        <pc:chgData name="Graf Thomas, SCS-INI-NET-VNC-E2E" userId="487bc3e3-9ce7-4cdd-b7b4-8899ea88d289" providerId="ADAL" clId="{ADEEF08A-D719-4B50-A383-4105EDA2C206}" dt="2026-07-22T04:50:58.353" v="2555" actId="1076"/>
-        <pc:sldMkLst>
-          <pc:docMk/>
-          <pc:sldMk cId="1859012803" sldId="271"/>
-        </pc:sldMkLst>
-        <pc:spChg chg="mod">
-          <ac:chgData name="Graf Thomas, SCS-INI-NET-VNC-E2E" userId="487bc3e3-9ce7-4cdd-b7b4-8899ea88d289" providerId="ADAL" clId="{ADEEF08A-D719-4B50-A383-4105EDA2C206}" dt="2026-07-16T09:16:30.343" v="1108" actId="20577"/>
-          <ac:spMkLst>
-            <pc:docMk/>
-            <pc:sldMk cId="1859012803" sldId="271"/>
-            <ac:spMk id="2" creationId="{0B9E15DC-F076-98D2-1BDF-BC01FEC9047B}"/>
-          </ac:spMkLst>
-        </pc:spChg>
-        <pc:spChg chg="add mod">
-          <ac:chgData name="Graf Thomas, SCS-INI-NET-VNC-E2E" userId="487bc3e3-9ce7-4cdd-b7b4-8899ea88d289" providerId="ADAL" clId="{ADEEF08A-D719-4B50-A383-4105EDA2C206}" dt="2026-07-16T09:18:06.653" v="1123" actId="1076"/>
-          <ac:spMkLst>
-            <pc:docMk/>
-            <pc:sldMk cId="1859012803" sldId="271"/>
-            <ac:spMk id="9" creationId="{7D37B510-93C9-AA3C-B299-9519676CBF6E}"/>
-          </ac:spMkLst>
-        </pc:spChg>
-        <pc:picChg chg="add mod">
-          <ac:chgData name="Graf Thomas, SCS-INI-NET-VNC-E2E" userId="487bc3e3-9ce7-4cdd-b7b4-8899ea88d289" providerId="ADAL" clId="{ADEEF08A-D719-4B50-A383-4105EDA2C206}" dt="2026-07-22T04:50:58.353" v="2555" actId="1076"/>
-          <ac:picMkLst>
-            <pc:docMk/>
-            <pc:sldMk cId="1859012803" sldId="271"/>
-            <ac:picMk id="5" creationId="{AEB91EE9-B558-492B-0B4C-5692B5522C42}"/>
-          </ac:picMkLst>
-        </pc:picChg>
-        <pc:picChg chg="add del mod">
-          <ac:chgData name="Graf Thomas, SCS-INI-NET-VNC-E2E" userId="487bc3e3-9ce7-4cdd-b7b4-8899ea88d289" providerId="ADAL" clId="{ADEEF08A-D719-4B50-A383-4105EDA2C206}" dt="2026-07-22T04:50:55.273" v="2553" actId="478"/>
-          <ac:picMkLst>
-            <pc:docMk/>
-            <pc:sldMk cId="1859012803" sldId="271"/>
-            <ac:picMk id="7" creationId="{2A4CF8FD-B7B0-9349-9F58-15E1143956C9}"/>
-          </ac:picMkLst>
-        </pc:picChg>
-      </pc:sldChg>
-      <pc:sldChg chg="del">
-        <pc:chgData name="Graf Thomas, SCS-INI-NET-VNC-E2E" userId="487bc3e3-9ce7-4cdd-b7b4-8899ea88d289" providerId="ADAL" clId="{ADEEF08A-D719-4B50-A383-4105EDA2C206}" dt="2026-07-16T09:19:27.094" v="1127" actId="47"/>
-        <pc:sldMkLst>
-          <pc:docMk/>
-          <pc:sldMk cId="915069421" sldId="273"/>
-        </pc:sldMkLst>
-      </pc:sldChg>
-      <pc:sldChg chg="addSp modSp add mod">
-        <pc:chgData name="Graf Thomas, SCS-INI-NET-VNC-E2E" userId="487bc3e3-9ce7-4cdd-b7b4-8899ea88d289" providerId="ADAL" clId="{ADEEF08A-D719-4B50-A383-4105EDA2C206}" dt="2026-07-16T10:10:50.107" v="2541" actId="255"/>
-        <pc:sldMkLst>
-          <pc:docMk/>
-          <pc:sldMk cId="3043113463" sldId="273"/>
-        </pc:sldMkLst>
-        <pc:spChg chg="mod">
-          <ac:chgData name="Graf Thomas, SCS-INI-NET-VNC-E2E" userId="487bc3e3-9ce7-4cdd-b7b4-8899ea88d289" providerId="ADAL" clId="{ADEEF08A-D719-4B50-A383-4105EDA2C206}" dt="2026-07-16T09:22:39.135" v="1145" actId="20577"/>
-          <ac:spMkLst>
-            <pc:docMk/>
-            <pc:sldMk cId="3043113463" sldId="273"/>
-            <ac:spMk id="2" creationId="{2793D84D-BA3F-4BC3-05B1-F1C6985A58BA}"/>
-          </ac:spMkLst>
-        </pc:spChg>
-        <pc:spChg chg="mod">
-          <ac:chgData name="Graf Thomas, SCS-INI-NET-VNC-E2E" userId="487bc3e3-9ce7-4cdd-b7b4-8899ea88d289" providerId="ADAL" clId="{ADEEF08A-D719-4B50-A383-4105EDA2C206}" dt="2026-07-16T10:10:35.494" v="2539" actId="948"/>
-          <ac:spMkLst>
-            <pc:docMk/>
-            <pc:sldMk cId="3043113463" sldId="273"/>
-            <ac:spMk id="3" creationId="{4C3CFCCD-25C3-F0B8-5E3F-E0F483354B56}"/>
-          </ac:spMkLst>
-        </pc:spChg>
-        <pc:spChg chg="add mod">
-          <ac:chgData name="Graf Thomas, SCS-INI-NET-VNC-E2E" userId="487bc3e3-9ce7-4cdd-b7b4-8899ea88d289" providerId="ADAL" clId="{ADEEF08A-D719-4B50-A383-4105EDA2C206}" dt="2026-07-16T10:10:50.107" v="2541" actId="255"/>
-          <ac:spMkLst>
-            <pc:docMk/>
-            <pc:sldMk cId="3043113463" sldId="273"/>
-            <ac:spMk id="8" creationId="{828DC0BA-F80F-FD0F-448C-2F7FEF399C05}"/>
-          </ac:spMkLst>
-        </pc:spChg>
-        <pc:picChg chg="add mod">
-          <ac:chgData name="Graf Thomas, SCS-INI-NET-VNC-E2E" userId="487bc3e3-9ce7-4cdd-b7b4-8899ea88d289" providerId="ADAL" clId="{ADEEF08A-D719-4B50-A383-4105EDA2C206}" dt="2026-07-16T09:45:26.124" v="2085" actId="1076"/>
-          <ac:picMkLst>
-            <pc:docMk/>
-            <pc:sldMk cId="3043113463" sldId="273"/>
-            <ac:picMk id="6" creationId="{BA2358F9-E859-21E8-71CB-113CB451D16A}"/>
-          </ac:picMkLst>
-        </pc:picChg>
-      </pc:sldChg>
-      <pc:sldChg chg="add del">
-        <pc:chgData name="Graf Thomas, SCS-INI-NET-VNC-E2E" userId="487bc3e3-9ce7-4cdd-b7b4-8899ea88d289" providerId="ADAL" clId="{ADEEF08A-D719-4B50-A383-4105EDA2C206}" dt="2026-03-16T02:22:09.813" v="337" actId="47"/>
-        <pc:sldMkLst>
-          <pc:docMk/>
-          <pc:sldMk cId="752615359" sldId="274"/>
-        </pc:sldMkLst>
-      </pc:sldChg>
-      <pc:sldChg chg="addSp modSp add del mod ord">
-        <pc:chgData name="Graf Thomas, SCS-INI-NET-VNC-E2E" userId="487bc3e3-9ce7-4cdd-b7b4-8899ea88d289" providerId="ADAL" clId="{ADEEF08A-D719-4B50-A383-4105EDA2C206}" dt="2026-07-16T09:19:27.094" v="1127" actId="47"/>
-        <pc:sldMkLst>
-          <pc:docMk/>
-          <pc:sldMk cId="1104703509" sldId="274"/>
-        </pc:sldMkLst>
-      </pc:sldChg>
-      <pc:sldChg chg="add del ord">
-        <pc:chgData name="Graf Thomas, SCS-INI-NET-VNC-E2E" userId="487bc3e3-9ce7-4cdd-b7b4-8899ea88d289" providerId="ADAL" clId="{ADEEF08A-D719-4B50-A383-4105EDA2C206}" dt="2026-03-16T02:52:04.115" v="589" actId="47"/>
-        <pc:sldMkLst>
-          <pc:docMk/>
-          <pc:sldMk cId="1432535309" sldId="275"/>
-        </pc:sldMkLst>
-      </pc:sldChg>
-    </pc:docChg>
-  </pc:docChgLst>
-  <pc:docChgLst>
-    <pc:chgData name="Graf Thomas, SCS-INI-NET-VNC-E2E" userId="487bc3e3-9ce7-4cdd-b7b4-8899ea88d289" providerId="ADAL" clId="{4725F99E-EFE0-4780-BB38-6BDDFB9F73C4}"/>
-    <pc:docChg chg="undo custSel delSld modSld">
-      <pc:chgData name="Graf Thomas, SCS-INI-NET-VNC-E2E" userId="487bc3e3-9ce7-4cdd-b7b4-8899ea88d289" providerId="ADAL" clId="{4725F99E-EFE0-4780-BB38-6BDDFB9F73C4}" dt="2025-10-27T07:49:36.115" v="1042" actId="20577"/>
-      <pc:docMkLst>
-        <pc:docMk/>
-      </pc:docMkLst>
-      <pc:sldChg chg="modSp mod">
-        <pc:chgData name="Graf Thomas, SCS-INI-NET-VNC-E2E" userId="487bc3e3-9ce7-4cdd-b7b4-8899ea88d289" providerId="ADAL" clId="{4725F99E-EFE0-4780-BB38-6BDDFB9F73C4}" dt="2025-10-27T07:43:43.844" v="1022" actId="790"/>
-        <pc:sldMkLst>
-          <pc:docMk/>
-          <pc:sldMk cId="0" sldId="256"/>
-        </pc:sldMkLst>
-      </pc:sldChg>
-      <pc:sldChg chg="modSp mod">
-        <pc:chgData name="Graf Thomas, SCS-INI-NET-VNC-E2E" userId="487bc3e3-9ce7-4cdd-b7b4-8899ea88d289" providerId="ADAL" clId="{4725F99E-EFE0-4780-BB38-6BDDFB9F73C4}" dt="2025-10-27T07:43:53.689" v="1023" actId="790"/>
-        <pc:sldMkLst>
-          <pc:docMk/>
-          <pc:sldMk cId="0" sldId="257"/>
-        </pc:sldMkLst>
-      </pc:sldChg>
-      <pc:sldChg chg="modSp mod">
-        <pc:chgData name="Graf Thomas, SCS-INI-NET-VNC-E2E" userId="487bc3e3-9ce7-4cdd-b7b4-8899ea88d289" providerId="ADAL" clId="{4725F99E-EFE0-4780-BB38-6BDDFB9F73C4}" dt="2025-10-27T07:44:00.397" v="1024" actId="790"/>
-        <pc:sldMkLst>
-          <pc:docMk/>
-          <pc:sldMk cId="0" sldId="258"/>
-        </pc:sldMkLst>
-      </pc:sldChg>
-      <pc:sldChg chg="modSp mod">
-        <pc:chgData name="Graf Thomas, SCS-INI-NET-VNC-E2E" userId="487bc3e3-9ce7-4cdd-b7b4-8899ea88d289" providerId="ADAL" clId="{4725F99E-EFE0-4780-BB38-6BDDFB9F73C4}" dt="2025-10-27T07:44:05.500" v="1025" actId="790"/>
-        <pc:sldMkLst>
-          <pc:docMk/>
-          <pc:sldMk cId="0" sldId="259"/>
-        </pc:sldMkLst>
-      </pc:sldChg>
-      <pc:sldChg chg="modSp mod">
-        <pc:chgData name="Graf Thomas, SCS-INI-NET-VNC-E2E" userId="487bc3e3-9ce7-4cdd-b7b4-8899ea88d289" providerId="ADAL" clId="{4725F99E-EFE0-4780-BB38-6BDDFB9F73C4}" dt="2025-10-27T07:48:29.201" v="1038" actId="14100"/>
-        <pc:sldMkLst>
-          <pc:docMk/>
-          <pc:sldMk cId="0" sldId="260"/>
-        </pc:sldMkLst>
-      </pc:sldChg>
-      <pc:sldChg chg="modSp mod">
-        <pc:chgData name="Graf Thomas, SCS-INI-NET-VNC-E2E" userId="487bc3e3-9ce7-4cdd-b7b4-8899ea88d289" providerId="ADAL" clId="{4725F99E-EFE0-4780-BB38-6BDDFB9F73C4}" dt="2025-10-27T07:44:34.772" v="1029" actId="790"/>
-        <pc:sldMkLst>
-          <pc:docMk/>
-          <pc:sldMk cId="3471097262" sldId="261"/>
-        </pc:sldMkLst>
-      </pc:sldChg>
-      <pc:sldChg chg="addSp delSp modSp mod">
-        <pc:chgData name="Graf Thomas, SCS-INI-NET-VNC-E2E" userId="487bc3e3-9ce7-4cdd-b7b4-8899ea88d289" providerId="ADAL" clId="{4725F99E-EFE0-4780-BB38-6BDDFB9F73C4}" dt="2025-10-27T07:44:42.065" v="1030" actId="790"/>
-        <pc:sldMkLst>
-          <pc:docMk/>
-          <pc:sldMk cId="2332748115" sldId="263"/>
-        </pc:sldMkLst>
-      </pc:sldChg>
-      <pc:sldChg chg="addSp delSp modSp mod">
-        <pc:chgData name="Graf Thomas, SCS-INI-NET-VNC-E2E" userId="487bc3e3-9ce7-4cdd-b7b4-8899ea88d289" providerId="ADAL" clId="{4725F99E-EFE0-4780-BB38-6BDDFB9F73C4}" dt="2025-10-27T07:48:38.632" v="1041" actId="14100"/>
-        <pc:sldMkLst>
-          <pc:docMk/>
-          <pc:sldMk cId="703495152" sldId="264"/>
-        </pc:sldMkLst>
-      </pc:sldChg>
-      <pc:sldChg chg="modSp mod">
-        <pc:chgData name="Graf Thomas, SCS-INI-NET-VNC-E2E" userId="487bc3e3-9ce7-4cdd-b7b4-8899ea88d289" providerId="ADAL" clId="{4725F99E-EFE0-4780-BB38-6BDDFB9F73C4}" dt="2025-10-27T07:48:32.985" v="1039" actId="14100"/>
-        <pc:sldMkLst>
-          <pc:docMk/>
-          <pc:sldMk cId="1372742302" sldId="266"/>
-        </pc:sldMkLst>
-      </pc:sldChg>
-      <pc:sldChg chg="modSp mod">
-        <pc:chgData name="Graf Thomas, SCS-INI-NET-VNC-E2E" userId="487bc3e3-9ce7-4cdd-b7b4-8899ea88d289" providerId="ADAL" clId="{4725F99E-EFE0-4780-BB38-6BDDFB9F73C4}" dt="2025-10-27T07:44:28.099" v="1028" actId="790"/>
-        <pc:sldMkLst>
-          <pc:docMk/>
-          <pc:sldMk cId="1383312952" sldId="267"/>
-        </pc:sldMkLst>
-      </pc:sldChg>
-      <pc:sldChg chg="modSp mod">
-        <pc:chgData name="Graf Thomas, SCS-INI-NET-VNC-E2E" userId="487bc3e3-9ce7-4cdd-b7b4-8899ea88d289" providerId="ADAL" clId="{4725F99E-EFE0-4780-BB38-6BDDFB9F73C4}" dt="2025-10-27T07:44:19.944" v="1027" actId="790"/>
-        <pc:sldMkLst>
-          <pc:docMk/>
-          <pc:sldMk cId="1659843495" sldId="268"/>
-        </pc:sldMkLst>
-      </pc:sldChg>
-      <pc:sldChg chg="modSp mod">
-        <pc:chgData name="Graf Thomas, SCS-INI-NET-VNC-E2E" userId="487bc3e3-9ce7-4cdd-b7b4-8899ea88d289" providerId="ADAL" clId="{4725F99E-EFE0-4780-BB38-6BDDFB9F73C4}" dt="2025-10-27T07:48:26.232" v="1037" actId="14100"/>
-        <pc:sldMkLst>
-          <pc:docMk/>
-          <pc:sldMk cId="2128497270" sldId="269"/>
-        </pc:sldMkLst>
-      </pc:sldChg>
-      <pc:sldChg chg="modSp mod">
-        <pc:chgData name="Graf Thomas, SCS-INI-NET-VNC-E2E" userId="487bc3e3-9ce7-4cdd-b7b4-8899ea88d289" providerId="ADAL" clId="{4725F99E-EFE0-4780-BB38-6BDDFB9F73C4}" dt="2025-10-27T07:49:36.115" v="1042" actId="20577"/>
-        <pc:sldMkLst>
-          <pc:docMk/>
-          <pc:sldMk cId="2434865477" sldId="270"/>
-        </pc:sldMkLst>
-      </pc:sldChg>
-      <pc:sldChg chg="addSp delSp modSp mod">
-        <pc:chgData name="Graf Thomas, SCS-INI-NET-VNC-E2E" userId="487bc3e3-9ce7-4cdd-b7b4-8899ea88d289" providerId="ADAL" clId="{4725F99E-EFE0-4780-BB38-6BDDFB9F73C4}" dt="2025-10-27T07:48:35.751" v="1040" actId="14100"/>
-        <pc:sldMkLst>
-          <pc:docMk/>
-          <pc:sldMk cId="1859012803" sldId="271"/>
-        </pc:sldMkLst>
-      </pc:sldChg>
-      <pc:sldChg chg="del">
-        <pc:chgData name="Graf Thomas, SCS-INI-NET-VNC-E2E" userId="487bc3e3-9ce7-4cdd-b7b4-8899ea88d289" providerId="ADAL" clId="{4725F99E-EFE0-4780-BB38-6BDDFB9F73C4}" dt="2025-10-27T07:29:31.409" v="861" actId="2696"/>
-        <pc:sldMkLst>
-          <pc:docMk/>
-          <pc:sldMk cId="333926329" sldId="272"/>
-        </pc:sldMkLst>
       </pc:sldChg>
     </pc:docChg>
   </pc:docChgLst>
@@ -30097,7 +29562,7 @@
         </p:nvSpPr>
         <p:spPr>
           <a:xfrm>
-            <a:off x="471899" y="1970468"/>
+            <a:off x="377275" y="1880414"/>
             <a:ext cx="8505845" cy="2658807"/>
           </a:xfrm>
         </p:spPr>
@@ -30176,13 +29641,10 @@
               <a:t>, AD review </a:t>
             </a:r>
             <a:r>
-              <a:rPr lang="en-US" sz="1400" dirty="0"/>
-              <a:t>received </a:t>
+              <a:rPr lang="en-US" sz="1400"/>
+              <a:t>received</a:t>
             </a:r>
-            <a:r>
-              <a:rPr lang="en-US" sz="1400" b="1" dirty="0"/>
-              <a:t>(on agenda tomorrow)</a:t>
-            </a:r>
+            <a:endParaRPr lang="en-US" sz="1400" b="1" dirty="0"/>
           </a:p>
           <a:p>
             <a:pPr>
@@ -30197,9 +29659,16 @@
               <a:t>draft-ietf-ippm-stamp-ext-hdr-11</a:t>
             </a:r>
             <a:r>
-              <a:rPr lang="en-US" sz="1400" dirty="0"/>
-              <a:t>, </a:t>
+              <a:rPr lang="en-001" sz="1400" dirty="0"/>
+              <a:t> WGLC concluded, waiting for shepherd writeup</a:t>
             </a:r>
+          </a:p>
+          <a:p>
+            <a:pPr>
+              <a:spcBef>
+                <a:spcPts val="600"/>
+              </a:spcBef>
+            </a:pPr>
             <a:r>
               <a:rPr lang="en-US" sz="1400" dirty="0">
                 <a:hlinkClick r:id="rId7"/>
@@ -30221,7 +29690,15 @@
             </a:r>
             <a:r>
               <a:rPr lang="en-US" sz="1400" dirty="0"/>
-              <a:t>in WG last call (</a:t>
+              <a:t>in WG</a:t>
+            </a:r>
+            <a:r>
+              <a:rPr lang="en-001" sz="1400" dirty="0"/>
+              <a:t>LC</a:t>
+            </a:r>
+            <a:r>
+              <a:rPr lang="en-US" sz="1400" dirty="0"/>
+              <a:t> (</a:t>
             </a:r>
             <a:r>
               <a:rPr lang="en-US" sz="1400" b="1" dirty="0"/>
@@ -31950,7 +31427,7 @@
         <p:fade/>
       </p:transition>
     </mc:Choice>
-    <mc:Fallback xmlns="" xmlns:mv="urn:schemas-microsoft-com:mac:vml" xmlns:c="http://schemas.openxmlformats.org/drawingml/2006/chart" xmlns:dgm="http://schemas.openxmlformats.org/drawingml/2006/diagram" xmlns:o="urn:schemas-microsoft-com:office:office" xmlns:v="urn:schemas-microsoft-com:vml" xmlns:pvml="urn:schemas-microsoft-com:office:powerpoint" xmlns:com="http://schemas.openxmlformats.org/drawingml/2006/compatibility" xmlns:p15="http://schemas.microsoft.com/office/powerpoint/2012/main" xmlns:ahyp="http://schemas.microsoft.com/office/drawing/2018/hyperlinkcolor">
+    <mc:Fallback xmlns:ahyp="http://schemas.microsoft.com/office/drawing/2018/hyperlinkcolor" xmlns:p15="http://schemas.microsoft.com/office/powerpoint/2012/main" xmlns:com="http://schemas.openxmlformats.org/drawingml/2006/compatibility" xmlns:pvml="urn:schemas-microsoft-com:office:powerpoint" xmlns:v="urn:schemas-microsoft-com:vml" xmlns:o="urn:schemas-microsoft-com:office:office" xmlns:dgm="http://schemas.openxmlformats.org/drawingml/2006/diagram" xmlns:c="http://schemas.openxmlformats.org/drawingml/2006/chart" xmlns:mv="urn:schemas-microsoft-com:mac:vml" xmlns="">
       <p:transition spd="slow">
         <p:fade/>
       </p:transition>
@@ -32273,7 +31750,7 @@
         <p:fade/>
       </p:transition>
     </mc:Choice>
-    <mc:Fallback xmlns="" xmlns:mv="urn:schemas-microsoft-com:mac:vml" xmlns:c="http://schemas.openxmlformats.org/drawingml/2006/chart" xmlns:dgm="http://schemas.openxmlformats.org/drawingml/2006/diagram" xmlns:o="urn:schemas-microsoft-com:office:office" xmlns:v="urn:schemas-microsoft-com:vml" xmlns:pvml="urn:schemas-microsoft-com:office:powerpoint" xmlns:com="http://schemas.openxmlformats.org/drawingml/2006/compatibility" xmlns:p15="http://schemas.microsoft.com/office/powerpoint/2012/main" xmlns:ahyp="http://schemas.microsoft.com/office/drawing/2018/hyperlinkcolor">
+    <mc:Fallback xmlns:ahyp="http://schemas.microsoft.com/office/drawing/2018/hyperlinkcolor" xmlns:p15="http://schemas.microsoft.com/office/powerpoint/2012/main" xmlns:com="http://schemas.openxmlformats.org/drawingml/2006/compatibility" xmlns:pvml="urn:schemas-microsoft-com:office:powerpoint" xmlns:v="urn:schemas-microsoft-com:vml" xmlns:o="urn:schemas-microsoft-com:office:office" xmlns:dgm="http://schemas.openxmlformats.org/drawingml/2006/diagram" xmlns:c="http://schemas.openxmlformats.org/drawingml/2006/chart" xmlns:mv="urn:schemas-microsoft-com:mac:vml" xmlns="">
       <p:transition spd="slow">
         <p:fade/>
       </p:transition>
@@ -35069,14 +34546,6 @@
 </file>
 
 <file path=customXml/item1.xml><?xml version="1.0" encoding="utf-8"?>
-<p:properties xmlns:p="http://schemas.microsoft.com/office/2006/metadata/properties" xmlns:xsi="http://www.w3.org/2001/XMLSchema-instance" xmlns:pc="http://schemas.microsoft.com/office/infopath/2007/PartnerControls">
-  <documentManagement>
-    <_activity xmlns="3e5e162a-5953-4fde-83b3-9639e6ab13bb" xsi:nil="true"/>
-  </documentManagement>
-</p:properties>
-</file>
-
-<file path=customXml/item2.xml><?xml version="1.0" encoding="utf-8"?>
 <ct:contentTypeSchema xmlns:ct="http://schemas.microsoft.com/office/2006/metadata/contentType" xmlns:ma="http://schemas.microsoft.com/office/2006/metadata/properties/metaAttributes" ct:_="" ma:_="" ma:contentTypeName="Dokument" ma:contentTypeID="0x01010028792A905D4FBE4781303B372FFF56B7" ma:contentTypeVersion="18" ma:contentTypeDescription="Ein neues Dokument erstellen." ma:contentTypeScope="" ma:versionID="1bed101c48ab8d637c0f10f3a19033d6">
   <xsd:schema xmlns:xsd="http://www.w3.org/2001/XMLSchema" xmlns:xs="http://www.w3.org/2001/XMLSchema" xmlns:p="http://schemas.microsoft.com/office/2006/metadata/properties" xmlns:ns3="3e5e162a-5953-4fde-83b3-9639e6ab13bb" xmlns:ns4="266fa233-377d-43d6-82a1-e70154e55ff7" targetNamespace="http://schemas.microsoft.com/office/2006/metadata/properties" ma:root="true" ma:fieldsID="ad54ca06dfd6fdd081bd33575dcf7e57" ns3:_="" ns4:_="">
     <xsd:import namespace="3e5e162a-5953-4fde-83b3-9639e6ab13bb"/>
@@ -35329,7 +34798,7 @@
 </ct:contentTypeSchema>
 </file>
 
-<file path=customXml/item3.xml><?xml version="1.0" encoding="utf-8"?>
+<file path=customXml/item2.xml><?xml version="1.0" encoding="utf-8"?>
 <?mso-contentType ?>
 <FormTemplates xmlns="http://schemas.microsoft.com/sharepoint/v3/contenttype/forms">
   <Display>DocumentLibraryForm</Display>
@@ -35338,24 +34807,15 @@
 </FormTemplates>
 </file>
 
-<file path=customXml/itemProps1.xml><?xml version="1.0" encoding="utf-8"?>
-<ds:datastoreItem xmlns:ds="http://schemas.openxmlformats.org/officeDocument/2006/customXml" ds:itemID="{3D7021EF-4D3D-4708-92FB-F2CD02CEF7A1}">
-  <ds:schemaRefs>
-    <ds:schemaRef ds:uri="http://purl.org/dc/elements/1.1/"/>
-    <ds:schemaRef ds:uri="3e5e162a-5953-4fde-83b3-9639e6ab13bb"/>
-    <ds:schemaRef ds:uri="266fa233-377d-43d6-82a1-e70154e55ff7"/>
-    <ds:schemaRef ds:uri="http://purl.org/dc/terms/"/>
-    <ds:schemaRef ds:uri="http://purl.org/dc/dcmitype/"/>
-    <ds:schemaRef ds:uri="http://schemas.microsoft.com/office/infopath/2007/PartnerControls"/>
-    <ds:schemaRef ds:uri="http://schemas.microsoft.com/office/2006/documentManagement/types"/>
-    <ds:schemaRef ds:uri="http://schemas.openxmlformats.org/package/2006/metadata/core-properties"/>
-    <ds:schemaRef ds:uri="http://schemas.microsoft.com/office/2006/metadata/properties"/>
-    <ds:schemaRef ds:uri="http://www.w3.org/XML/1998/namespace"/>
-  </ds:schemaRefs>
-</ds:datastoreItem>
+<file path=customXml/item3.xml><?xml version="1.0" encoding="utf-8"?>
+<p:properties xmlns:p="http://schemas.microsoft.com/office/2006/metadata/properties" xmlns:xsi="http://www.w3.org/2001/XMLSchema-instance" xmlns:pc="http://schemas.microsoft.com/office/infopath/2007/PartnerControls">
+  <documentManagement>
+    <_activity xmlns="3e5e162a-5953-4fde-83b3-9639e6ab13bb" xsi:nil="true"/>
+  </documentManagement>
+</p:properties>
 </file>
 
-<file path=customXml/itemProps2.xml><?xml version="1.0" encoding="utf-8"?>
+<file path=customXml/itemProps1.xml><?xml version="1.0" encoding="utf-8"?>
 <ds:datastoreItem xmlns:ds="http://schemas.openxmlformats.org/officeDocument/2006/customXml" ds:itemID="{F4805544-B524-4E4A-B7C1-6ABFC599928D}">
   <ds:schemaRefs>
     <ds:schemaRef ds:uri="http://schemas.microsoft.com/office/2006/metadata/contentType"/>
@@ -35374,10 +34834,27 @@
 </ds:datastoreItem>
 </file>
 
-<file path=customXml/itemProps3.xml><?xml version="1.0" encoding="utf-8"?>
+<file path=customXml/itemProps2.xml><?xml version="1.0" encoding="utf-8"?>
 <ds:datastoreItem xmlns:ds="http://schemas.openxmlformats.org/officeDocument/2006/customXml" ds:itemID="{9104BBC9-6B71-4DC1-A0E0-1E198363AC7F}">
   <ds:schemaRefs>
     <ds:schemaRef ds:uri="http://schemas.microsoft.com/sharepoint/v3/contenttype/forms"/>
+  </ds:schemaRefs>
+</ds:datastoreItem>
+</file>
+
+<file path=customXml/itemProps3.xml><?xml version="1.0" encoding="utf-8"?>
+<ds:datastoreItem xmlns:ds="http://schemas.openxmlformats.org/officeDocument/2006/customXml" ds:itemID="{3D7021EF-4D3D-4708-92FB-F2CD02CEF7A1}">
+  <ds:schemaRefs>
+    <ds:schemaRef ds:uri="http://purl.org/dc/elements/1.1/"/>
+    <ds:schemaRef ds:uri="3e5e162a-5953-4fde-83b3-9639e6ab13bb"/>
+    <ds:schemaRef ds:uri="266fa233-377d-43d6-82a1-e70154e55ff7"/>
+    <ds:schemaRef ds:uri="http://purl.org/dc/terms/"/>
+    <ds:schemaRef ds:uri="http://purl.org/dc/dcmitype/"/>
+    <ds:schemaRef ds:uri="http://schemas.microsoft.com/office/infopath/2007/PartnerControls"/>
+    <ds:schemaRef ds:uri="http://schemas.microsoft.com/office/2006/documentManagement/types"/>
+    <ds:schemaRef ds:uri="http://schemas.openxmlformats.org/package/2006/metadata/core-properties"/>
+    <ds:schemaRef ds:uri="http://schemas.microsoft.com/office/2006/metadata/properties"/>
+    <ds:schemaRef ds:uri="http://www.w3.org/XML/1998/namespace"/>
   </ds:schemaRefs>
 </ds:datastoreItem>
 </file>

</xml_diff>